<commit_message>
fix: keep training marker out of mergeable source
</commit_message>
<xml_diff>
--- a/decks/02-github-pr-control-bento-swiss.pptx
+++ b/decks/02-github-pr-control-bento-swiss.pptx
@@ -3995,7 +3995,7 @@
         <p:spPr>
           <a:xfrm>
             <a:off x="749808" y="2788920"/>
-            <a:ext cx="1097280" cy="301752"/>
+            <a:ext cx="1508760" cy="301752"/>
           </a:xfrm>
           <a:prstGeom prst="roundRect">
             <a:avLst>
@@ -4042,7 +4042,7 @@
         <p:spPr>
           <a:xfrm>
             <a:off x="786384" y="2843784"/>
-            <a:ext cx="1005840" cy="146304"/>
+            <a:ext cx="1417320" cy="146304"/>
           </a:xfrm>
           <a:prstGeom prst="rect">
             <a:avLst/>
@@ -4076,8 +4076,8 @@
         </p:nvSpPr>
         <p:spPr>
           <a:xfrm>
-            <a:off x="2048255" y="2788920"/>
-            <a:ext cx="1097280" cy="301752"/>
+            <a:off x="2487168" y="2788920"/>
+            <a:ext cx="1508760" cy="301752"/>
           </a:xfrm>
           <a:prstGeom prst="roundRect">
             <a:avLst>
@@ -4123,8 +4123,8 @@
         </p:nvSpPr>
         <p:spPr>
           <a:xfrm>
-            <a:off x="2084831" y="2843784"/>
-            <a:ext cx="1005840" cy="146304"/>
+            <a:off x="2523744" y="2843784"/>
+            <a:ext cx="1417320" cy="146304"/>
           </a:xfrm>
           <a:prstGeom prst="rect">
             <a:avLst/>
@@ -4481,7 +4481,7 @@
         <p:spPr>
           <a:xfrm>
             <a:off x="749808" y="2788920"/>
-            <a:ext cx="1097280" cy="301752"/>
+            <a:ext cx="1508760" cy="301752"/>
           </a:xfrm>
           <a:prstGeom prst="roundRect">
             <a:avLst>
@@ -4528,7 +4528,7 @@
         <p:spPr>
           <a:xfrm>
             <a:off x="786384" y="2843784"/>
-            <a:ext cx="1005840" cy="146304"/>
+            <a:ext cx="1417320" cy="146304"/>
           </a:xfrm>
           <a:prstGeom prst="rect">
             <a:avLst/>
@@ -4562,8 +4562,8 @@
         </p:nvSpPr>
         <p:spPr>
           <a:xfrm>
-            <a:off x="2048255" y="2788920"/>
-            <a:ext cx="1097280" cy="301752"/>
+            <a:off x="2487168" y="2788920"/>
+            <a:ext cx="1508760" cy="301752"/>
           </a:xfrm>
           <a:prstGeom prst="roundRect">
             <a:avLst>
@@ -4609,8 +4609,8 @@
         </p:nvSpPr>
         <p:spPr>
           <a:xfrm>
-            <a:off x="2084831" y="2843784"/>
-            <a:ext cx="1005840" cy="146304"/>
+            <a:off x="2523744" y="2843784"/>
+            <a:ext cx="1417320" cy="146304"/>
           </a:xfrm>
           <a:prstGeom prst="rect">
             <a:avLst/>
@@ -4967,7 +4967,7 @@
         <p:spPr>
           <a:xfrm>
             <a:off x="749808" y="2788920"/>
-            <a:ext cx="1097280" cy="301752"/>
+            <a:ext cx="1508760" cy="301752"/>
           </a:xfrm>
           <a:prstGeom prst="roundRect">
             <a:avLst>
@@ -5014,7 +5014,7 @@
         <p:spPr>
           <a:xfrm>
             <a:off x="786384" y="2843784"/>
-            <a:ext cx="1005840" cy="146304"/>
+            <a:ext cx="1417320" cy="146304"/>
           </a:xfrm>
           <a:prstGeom prst="rect">
             <a:avLst/>
@@ -5048,8 +5048,8 @@
         </p:nvSpPr>
         <p:spPr>
           <a:xfrm>
-            <a:off x="2048255" y="2788920"/>
-            <a:ext cx="1097280" cy="301752"/>
+            <a:off x="2487168" y="2788920"/>
+            <a:ext cx="1508760" cy="301752"/>
           </a:xfrm>
           <a:prstGeom prst="roundRect">
             <a:avLst>
@@ -5095,8 +5095,8 @@
         </p:nvSpPr>
         <p:spPr>
           <a:xfrm>
-            <a:off x="2084831" y="2843784"/>
-            <a:ext cx="1005840" cy="146304"/>
+            <a:off x="2523744" y="2843784"/>
+            <a:ext cx="1417320" cy="146304"/>
           </a:xfrm>
           <a:prstGeom prst="rect">
             <a:avLst/>
@@ -13944,7 +13944,7 @@
         <p:spPr>
           <a:xfrm>
             <a:off x="749808" y="2788920"/>
-            <a:ext cx="1097280" cy="301752"/>
+            <a:ext cx="1508760" cy="301752"/>
           </a:xfrm>
           <a:prstGeom prst="roundRect">
             <a:avLst>
@@ -13991,7 +13991,7 @@
         <p:spPr>
           <a:xfrm>
             <a:off x="786384" y="2843784"/>
-            <a:ext cx="1005840" cy="146304"/>
+            <a:ext cx="1417320" cy="146304"/>
           </a:xfrm>
           <a:prstGeom prst="rect">
             <a:avLst/>
@@ -14025,8 +14025,8 @@
         </p:nvSpPr>
         <p:spPr>
           <a:xfrm>
-            <a:off x="2048255" y="2788920"/>
-            <a:ext cx="1097280" cy="301752"/>
+            <a:off x="2487168" y="2788920"/>
+            <a:ext cx="1508760" cy="301752"/>
           </a:xfrm>
           <a:prstGeom prst="roundRect">
             <a:avLst>
@@ -14072,8 +14072,8 @@
         </p:nvSpPr>
         <p:spPr>
           <a:xfrm>
-            <a:off x="2084831" y="2843784"/>
-            <a:ext cx="1005840" cy="146304"/>
+            <a:off x="2523744" y="2843784"/>
+            <a:ext cx="1417320" cy="146304"/>
           </a:xfrm>
           <a:prstGeom prst="rect">
             <a:avLst/>
@@ -14430,7 +14430,7 @@
         <p:spPr>
           <a:xfrm>
             <a:off x="749808" y="2788920"/>
-            <a:ext cx="1097280" cy="301752"/>
+            <a:ext cx="1508760" cy="301752"/>
           </a:xfrm>
           <a:prstGeom prst="roundRect">
             <a:avLst>
@@ -14477,7 +14477,7 @@
         <p:spPr>
           <a:xfrm>
             <a:off x="786384" y="2843784"/>
-            <a:ext cx="1005840" cy="146304"/>
+            <a:ext cx="1417320" cy="146304"/>
           </a:xfrm>
           <a:prstGeom prst="rect">
             <a:avLst/>
@@ -14511,8 +14511,8 @@
         </p:nvSpPr>
         <p:spPr>
           <a:xfrm>
-            <a:off x="2048255" y="2788920"/>
-            <a:ext cx="1097280" cy="301752"/>
+            <a:off x="2487168" y="2788920"/>
+            <a:ext cx="1508760" cy="301752"/>
           </a:xfrm>
           <a:prstGeom prst="roundRect">
             <a:avLst>
@@ -14558,8 +14558,8 @@
         </p:nvSpPr>
         <p:spPr>
           <a:xfrm>
-            <a:off x="2084831" y="2843784"/>
-            <a:ext cx="1005840" cy="146304"/>
+            <a:off x="2523744" y="2843784"/>
+            <a:ext cx="1417320" cy="146304"/>
           </a:xfrm>
           <a:prstGeom prst="rect">
             <a:avLst/>

</xml_diff>